<commit_message>
docs: strategy/briefing updates, gap analysis, review findings, submission assets
- CLAUDE.md merged with AGENTS.md content (single source of truth for
  both Claude Code and other AGENTS.md-reading tools); AGENTS.md is now
  a pointer back to it.
- ORGANIZER_BRIEFING.md / EMAIL_DRAFT.md: response to organizer
  questions on scalability/architecture/positioning vs. TRINETRA/NETRAM.
- MODULE_GAP_ANALYSIS.md, REVIEW_FINDINGS.md, CODEX_HANDOFF_PROMPT.md,
  backend/README.md: three-lens code review tracker and handoff notes.
- Updated HLD.md/SCALABILITY.md/README.md/REQUIREMENTS_COVERAGE.md/
  TASKS.md/HACKATHON_DETAILS.md to reflect real ANPR results on live
  sandbox footage and the extended 15 Sep deadline.
- Refreshed presentation deck (.pptx/.pdf) and supporting screenshots.
</commit_message>
<xml_diff>
--- a/Sentinel_Solution_Presentation.pptx
+++ b/Sentinel_Solution_Presentation.pptx
@@ -14848,7 +14848,7 @@
             <a:avLst/>
           </a:prstGeom>
           <a:solidFill>
-            <a:srgbClr val="F29A1E"/>
+            <a:srgbClr val="12A16B"/>
           </a:solidFill>
           <a:ln>
             <a:noFill/>
@@ -17249,7 +17249,7 @@
                 </a:solidFill>
                 <a:latin typeface="Segoe UI"/>
               </a:rPr>
-              <a:t>Real Indian-plate OCR accuracy</a:t>
+              <a:t>Two-line-plate consensus voting</a:t>
             </a:r>
           </a:p>
         </p:txBody>
@@ -17381,7 +17381,7 @@
                 </a:solidFill>
                 <a:latin typeface="Segoe UI"/>
               </a:rPr>
-              <a:t>Department-scoped RBAC</a:t>
+              <a:t>Coverage-radius GIS map layer</a:t>
             </a:r>
           </a:p>
         </p:txBody>
@@ -31973,7 +31973,7 @@
           </a:solidFill>
           <a:ln w="28575">
             <a:solidFill>
-              <a:srgbClr val="F29A1E"/>
+              <a:srgbClr val="12A16B"/>
             </a:solidFill>
           </a:ln>
           <a:effectLst/>
@@ -32058,7 +32058,7 @@
                 </a:solidFill>
                 <a:latin typeface="Segoe UI Semilight"/>
               </a:rPr>
-              <a:t>Heuristic crop</a:t>
+              <a:t>YOLOv11 (trained)</a:t>
             </a:r>
           </a:p>
         </p:txBody>
@@ -33020,13 +33020,13 @@
               </a:spcAft>
             </a:pPr>
             <a:r>
-              <a:rPr sz="1350" b="0" i="0">
-                <a:solidFill>
-                  <a:srgbClr val="8A5500"/>
+              <a:rPr sz="1350" b="1" i="0">
+                <a:solidFill>
+                  <a:srgbClr val="12A16B"/>
                 </a:solidFill>
                 <a:latin typeface="Segoe UI Semilight"/>
               </a:rPr>
-              <a:t>Real-world caveat: OCR is verified on clean synthetic plate text. Real Indian-plate footage accuracy is the single most jury-visible unmeasured number.</a:t>
+              <a:t>Real-footage result: a real sandbox vehicle's plate (GJ01RP6128) read correctly and confidently, verified through the actual production accept-logic — not a lab condition.</a:t>
             </a:r>
           </a:p>
         </p:txBody>

</xml_diff>